<commit_message>
Correct retraining claim; fix stale README layout; drop publication-strategy slide
</commit_message>
<xml_diff>
--- a/CCP_findings.pptx
+++ b/CCP_findings.pptx
@@ -4399,7 +4399,7 @@
                   <a:srgbClr val="1F4E79"/>
                 </a:solidFill>
               </a:rPr>
-              <a:t>Status, publishability, next steps</a:t>
+              <a:t>Status</a:t>
             </a:r>
           </a:p>
         </p:txBody>
@@ -4438,76 +4438,6 @@
                 </a:solidFill>
               </a:rPr>
               <a:t>•  STATUS:  reproduction GO  ·  exact-edge calibration NO-GO  ·  region calibration WORKS.</a:t>
-            </a:r>
-          </a:p>
-          <a:p>
-            <a:pPr>
-              <a:spcAft>
-                <a:spcPts val="600"/>
-              </a:spcAft>
-            </a:pPr>
-            <a:r>
-              <a:rPr sz="1800" b="0"/>
-              <a:t>•  PUBLISHABILITY (honest): a plausible mid-tier paper (JBI / JAMIA Open / J. Biomed. Semantics).</a:t>
-            </a:r>
-          </a:p>
-          <a:p>
-            <a:pPr>
-              <a:spcAft>
-                <a:spcPts val="600"/>
-              </a:spcAft>
-            </a:pPr>
-            <a:r>
-              <a:rPr sz="1800" b="0"/>
-              <a:t>•     Strength: novel reliability/curator-usability angle; the confidence-tracks-region finding.</a:t>
-            </a:r>
-          </a:p>
-          <a:p>
-            <a:pPr>
-              <a:spcAft>
-                <a:spcPts val="600"/>
-              </a:spcAft>
-            </a:pPr>
-            <a:r>
-              <a:rPr sz="1800" b="0"/>
-              <a:t>•     Risks to manage: the coverage guarantee undershoots (drift); single small dataset; modest novelty.</a:t>
-            </a:r>
-          </a:p>
-          <a:p>
-            <a:pPr>
-              <a:spcAft>
-                <a:spcPts val="600"/>
-              </a:spcAft>
-            </a:pPr>
-            <a:r>
-              <a:rPr sz="1800" b="0"/>
-              <a:t>•     → Reframe headline to risk-coverage/curator-triage (robust to drift), and add a 2nd dataset.</a:t>
-            </a:r>
-          </a:p>
-          <a:p>
-            <a:pPr>
-              <a:spcAft>
-                <a:spcPts val="600"/>
-              </a:spcAft>
-            </a:pPr>
-            <a:r>
-              <a:rPr sz="1800" b="0">
-                <a:solidFill>
-                  <a:srgbClr val="1F4E79"/>
-                </a:solidFill>
-              </a:rPr>
-              <a:t>•  NEXT:  CPP benchmark running now (job 326, 432 test mentions) → cross-dataset generalization;</a:t>
-            </a:r>
-          </a:p>
-          <a:p>
-            <a:pPr>
-              <a:spcAft>
-                <a:spcPts val="600"/>
-              </a:spcAft>
-            </a:pPr>
-            <a:r>
-              <a:rPr sz="1800" b="0"/>
-              <a:t>•            then class-conditional refinement + write-up.</a:t>
             </a:r>
           </a:p>
         </p:txBody>

</xml_diff>